<commit_message>
3D plot working well
</commit_message>
<xml_diff>
--- a/presentations/figures for patent application.pptx
+++ b/presentations/figures for patent application.pptx
@@ -6144,6 +6144,42 @@
           <a:chExt cx="0" cy="0"/>
         </a:xfrm>
       </p:grpSpPr>
+      <p:pic>
+        <p:nvPicPr>
+          <p:cNvPr id="20" name="Picture 19" descr="A graph of a graph showing a number of different sizes&#10;&#10;AI-generated content may be incorrect.">
+            <a:extLst>
+              <a:ext uri="{FF2B5EF4-FFF2-40B4-BE49-F238E27FC236}">
+                <a16:creationId xmlns:a16="http://schemas.microsoft.com/office/drawing/2014/main" id="{AFC49084-0ABB-74FA-9569-6233A0B03A1B}"/>
+              </a:ext>
+            </a:extLst>
+          </p:cNvPr>
+          <p:cNvPicPr>
+            <a:picLocks noChangeAspect="1"/>
+          </p:cNvPicPr>
+          <p:nvPr/>
+        </p:nvPicPr>
+        <p:blipFill>
+          <a:blip r:embed="rId2">
+            <a:extLst>
+              <a:ext uri="{28A0092B-C50C-407E-A947-70E740481C1C}">
+                <a14:useLocalDpi xmlns:a14="http://schemas.microsoft.com/office/drawing/2010/main" val="0"/>
+              </a:ext>
+            </a:extLst>
+          </a:blip>
+          <a:stretch>
+            <a:fillRect/>
+          </a:stretch>
+        </p:blipFill>
+        <p:spPr>
+          <a:xfrm>
+            <a:off x="2774294" y="1696651"/>
+            <a:ext cx="6400813" cy="3950216"/>
+          </a:xfrm>
+          <a:prstGeom prst="rect">
+            <a:avLst/>
+          </a:prstGeom>
+        </p:spPr>
+      </p:pic>
       <p:sp>
         <p:nvSpPr>
           <p:cNvPr id="2" name="Title 1">
@@ -6165,6 +6201,286 @@
           <a:bodyPr/>
           <a:lstStyle/>
           <a:p>
+            <a:endParaRPr lang="en-US"/>
+          </a:p>
+        </p:txBody>
+      </p:sp>
+      <p:sp>
+        <p:nvSpPr>
+          <p:cNvPr id="6" name="TextBox 5">
+            <a:extLst>
+              <a:ext uri="{FF2B5EF4-FFF2-40B4-BE49-F238E27FC236}">
+                <a16:creationId xmlns:a16="http://schemas.microsoft.com/office/drawing/2014/main" id="{A356BE26-A1D0-866B-769F-640B2A8B8E8F}"/>
+              </a:ext>
+            </a:extLst>
+          </p:cNvPr>
+          <p:cNvSpPr txBox="1"/>
+          <p:nvPr/>
+        </p:nvSpPr>
+        <p:spPr>
+          <a:xfrm>
+            <a:off x="7692845" y="3390237"/>
+            <a:ext cx="924127" cy="230832"/>
+          </a:xfrm>
+          <a:prstGeom prst="rect">
+            <a:avLst/>
+          </a:prstGeom>
+          <a:solidFill>
+            <a:schemeClr val="bg1"/>
+          </a:solidFill>
+        </p:spPr>
+        <p:txBody>
+          <a:bodyPr wrap="square" rtlCol="0">
+            <a:spAutoFit/>
+          </a:bodyPr>
+          <a:lstStyle/>
+          <a:p>
+            <a:r>
+              <a:rPr lang="en-US" sz="900" b="1" dirty="0"/>
+              <a:t>1680 features</a:t>
+            </a:r>
+          </a:p>
+        </p:txBody>
+      </p:sp>
+      <p:sp>
+        <p:nvSpPr>
+          <p:cNvPr id="7" name="TextBox 6">
+            <a:extLst>
+              <a:ext uri="{FF2B5EF4-FFF2-40B4-BE49-F238E27FC236}">
+                <a16:creationId xmlns:a16="http://schemas.microsoft.com/office/drawing/2014/main" id="{6B0CBEE1-92EB-25CC-1740-A66B84850DE2}"/>
+              </a:ext>
+            </a:extLst>
+          </p:cNvPr>
+          <p:cNvSpPr txBox="1"/>
+          <p:nvPr/>
+        </p:nvSpPr>
+        <p:spPr>
+          <a:xfrm>
+            <a:off x="7692845" y="2428028"/>
+            <a:ext cx="886407" cy="230832"/>
+          </a:xfrm>
+          <a:prstGeom prst="rect">
+            <a:avLst/>
+          </a:prstGeom>
+          <a:noFill/>
+        </p:spPr>
+        <p:txBody>
+          <a:bodyPr wrap="square" rtlCol="0">
+            <a:spAutoFit/>
+          </a:bodyPr>
+          <a:lstStyle/>
+          <a:p>
+            <a:r>
+              <a:rPr lang="en-US" sz="900" b="1" dirty="0"/>
+              <a:t>3289 features</a:t>
+            </a:r>
+          </a:p>
+        </p:txBody>
+      </p:sp>
+      <p:sp>
+        <p:nvSpPr>
+          <p:cNvPr id="21" name="TextBox 20">
+            <a:extLst>
+              <a:ext uri="{FF2B5EF4-FFF2-40B4-BE49-F238E27FC236}">
+                <a16:creationId xmlns:a16="http://schemas.microsoft.com/office/drawing/2014/main" id="{E783C494-891C-E00B-1438-3FBDAAD6B216}"/>
+              </a:ext>
+            </a:extLst>
+          </p:cNvPr>
+          <p:cNvSpPr txBox="1"/>
+          <p:nvPr/>
+        </p:nvSpPr>
+        <p:spPr>
+          <a:xfrm>
+            <a:off x="7547572" y="4660804"/>
+            <a:ext cx="1418252" cy="507831"/>
+          </a:xfrm>
+          <a:prstGeom prst="rect">
+            <a:avLst/>
+          </a:prstGeom>
+          <a:noFill/>
+        </p:spPr>
+        <p:txBody>
+          <a:bodyPr wrap="square" rtlCol="0">
+            <a:spAutoFit/>
+          </a:bodyPr>
+          <a:lstStyle/>
+          <a:p>
+            <a:r>
+              <a:rPr lang="en-US" sz="900" b="1" dirty="0">
+                <a:latin typeface="Arial" panose="020B0604020202020204" pitchFamily="34" charset="0"/>
+                <a:cs typeface="Arial" panose="020B0604020202020204" pitchFamily="34" charset="0"/>
+              </a:rPr>
+              <a:t>Point below cutoff</a:t>
+            </a:r>
+          </a:p>
+          <a:p>
+            <a:r>
+              <a:rPr lang="en-US" sz="900" b="1" dirty="0">
+                <a:latin typeface="Arial" panose="020B0604020202020204" pitchFamily="34" charset="0"/>
+                <a:cs typeface="Arial" panose="020B0604020202020204" pitchFamily="34" charset="0"/>
+              </a:rPr>
+              <a:t>Point above cutoff</a:t>
+            </a:r>
+          </a:p>
+          <a:p>
+            <a:r>
+              <a:rPr lang="en-US" sz="900" b="1" dirty="0">
+                <a:latin typeface="Arial" panose="020B0604020202020204" pitchFamily="34" charset="0"/>
+                <a:cs typeface="Arial" panose="020B0604020202020204" pitchFamily="34" charset="0"/>
+              </a:rPr>
+              <a:t>PFAS suspect</a:t>
+            </a:r>
+          </a:p>
+        </p:txBody>
+      </p:sp>
+      <p:sp>
+        <p:nvSpPr>
+          <p:cNvPr id="23" name="Oval 22">
+            <a:extLst>
+              <a:ext uri="{FF2B5EF4-FFF2-40B4-BE49-F238E27FC236}">
+                <a16:creationId xmlns:a16="http://schemas.microsoft.com/office/drawing/2014/main" id="{8DE6D488-E57F-98DB-EB9F-1A6AC35BC4E2}"/>
+              </a:ext>
+            </a:extLst>
+          </p:cNvPr>
+          <p:cNvSpPr/>
+          <p:nvPr/>
+        </p:nvSpPr>
+        <p:spPr>
+          <a:xfrm>
+            <a:off x="7481888" y="4737487"/>
+            <a:ext cx="95250" cy="91440"/>
+          </a:xfrm>
+          <a:prstGeom prst="ellipse">
+            <a:avLst/>
+          </a:prstGeom>
+          <a:noFill/>
+        </p:spPr>
+        <p:style>
+          <a:lnRef idx="2">
+            <a:schemeClr val="accent1">
+              <a:shade val="15000"/>
+            </a:schemeClr>
+          </a:lnRef>
+          <a:fillRef idx="1">
+            <a:schemeClr val="accent1"/>
+          </a:fillRef>
+          <a:effectRef idx="0">
+            <a:schemeClr val="accent1"/>
+          </a:effectRef>
+          <a:fontRef idx="minor">
+            <a:schemeClr val="lt1"/>
+          </a:fontRef>
+        </p:style>
+        <p:txBody>
+          <a:bodyPr rtlCol="0" anchor="ctr"/>
+          <a:lstStyle/>
+          <a:p>
+            <a:pPr algn="ctr"/>
+            <a:endParaRPr lang="en-US"/>
+          </a:p>
+        </p:txBody>
+      </p:sp>
+      <p:sp>
+        <p:nvSpPr>
+          <p:cNvPr id="24" name="Oval 23">
+            <a:extLst>
+              <a:ext uri="{FF2B5EF4-FFF2-40B4-BE49-F238E27FC236}">
+                <a16:creationId xmlns:a16="http://schemas.microsoft.com/office/drawing/2014/main" id="{613B9BEA-63E8-D97D-66CA-9426FEDF1E88}"/>
+              </a:ext>
+            </a:extLst>
+          </p:cNvPr>
+          <p:cNvSpPr/>
+          <p:nvPr/>
+        </p:nvSpPr>
+        <p:spPr>
+          <a:xfrm>
+            <a:off x="7481888" y="4868999"/>
+            <a:ext cx="95250" cy="91440"/>
+          </a:xfrm>
+          <a:prstGeom prst="ellipse">
+            <a:avLst/>
+          </a:prstGeom>
+          <a:solidFill>
+            <a:schemeClr val="tx1"/>
+          </a:solidFill>
+          <a:ln>
+            <a:solidFill>
+              <a:schemeClr val="tx1"/>
+            </a:solidFill>
+          </a:ln>
+        </p:spPr>
+        <p:style>
+          <a:lnRef idx="2">
+            <a:schemeClr val="accent1">
+              <a:shade val="15000"/>
+            </a:schemeClr>
+          </a:lnRef>
+          <a:fillRef idx="1">
+            <a:schemeClr val="accent1"/>
+          </a:fillRef>
+          <a:effectRef idx="0">
+            <a:schemeClr val="accent1"/>
+          </a:effectRef>
+          <a:fontRef idx="minor">
+            <a:schemeClr val="lt1"/>
+          </a:fontRef>
+        </p:style>
+        <p:txBody>
+          <a:bodyPr rtlCol="0" anchor="ctr"/>
+          <a:lstStyle/>
+          <a:p>
+            <a:pPr algn="ctr"/>
+            <a:endParaRPr lang="en-US"/>
+          </a:p>
+        </p:txBody>
+      </p:sp>
+      <p:sp>
+        <p:nvSpPr>
+          <p:cNvPr id="25" name="Multiplication Sign 24">
+            <a:extLst>
+              <a:ext uri="{FF2B5EF4-FFF2-40B4-BE49-F238E27FC236}">
+                <a16:creationId xmlns:a16="http://schemas.microsoft.com/office/drawing/2014/main" id="{46D82F40-4B13-0EFF-526B-04567C36BDD9}"/>
+              </a:ext>
+            </a:extLst>
+          </p:cNvPr>
+          <p:cNvSpPr/>
+          <p:nvPr/>
+        </p:nvSpPr>
+        <p:spPr>
+          <a:xfrm>
+            <a:off x="7447359" y="4960439"/>
+            <a:ext cx="164307" cy="166801"/>
+          </a:xfrm>
+          <a:prstGeom prst="mathMultiply">
+            <a:avLst>
+              <a:gd name="adj1" fmla="val 15708"/>
+            </a:avLst>
+          </a:prstGeom>
+          <a:solidFill>
+            <a:schemeClr val="tx1"/>
+          </a:solidFill>
+        </p:spPr>
+        <p:style>
+          <a:lnRef idx="2">
+            <a:schemeClr val="accent1">
+              <a:shade val="15000"/>
+            </a:schemeClr>
+          </a:lnRef>
+          <a:fillRef idx="1">
+            <a:schemeClr val="accent1"/>
+          </a:fillRef>
+          <a:effectRef idx="0">
+            <a:schemeClr val="accent1"/>
+          </a:effectRef>
+          <a:fontRef idx="minor">
+            <a:schemeClr val="lt1"/>
+          </a:fontRef>
+        </p:style>
+        <p:txBody>
+          <a:bodyPr rtlCol="0" anchor="ctr"/>
+          <a:lstStyle/>
+          <a:p>
+            <a:pPr algn="ctr"/>
             <a:endParaRPr lang="en-US"/>
           </a:p>
         </p:txBody>

</xml_diff>